<commit_message>
docs(readme+deck): add real IPS Map screenshots (live traffic globe)
User captured the live /ips page. Adds two real screenshots — the traffic
globe with KPIs/top sources (ips.png) and the live events feed (ips-events.png)
— to the README IPS section alongside the animated GIF, and swaps the
illustrative IPS tile on the technical deck's Platform Tour slide for the
real globe capture.

Co-Authored-By: Claude Opus 4.8 <noreply@anthropic.com>
</commit_message>
<xml_diff>
--- a/Presntations/ARIA_Technical_Presentation_Ghazi_Mabrouki_FINAL.pptx
+++ b/Presntations/ARIA_Technical_Presentation_Ghazi_Mabrouki_FINAL.pptx
@@ -25683,16 +25683,86 @@
           </a:p>
         </p:txBody>
       </p:sp>
+      <p:sp>
+        <p:nvSpPr>
+          <p:cNvPr id="6" name="TextBox 5"/>
+          <p:cNvSpPr txBox="1"/>
+          <p:nvPr/>
+        </p:nvSpPr>
+        <p:spPr>
+          <a:xfrm>
+            <a:off x="571500" y="6629400"/>
+            <a:ext cx="1904695" cy="152704"/>
+          </a:xfrm>
+          <a:prstGeom prst="rect">
+            <a:avLst/>
+          </a:prstGeom>
+          <a:noFill/>
+        </p:spPr>
+        <p:txBody>
+          <a:bodyPr wrap="square" lIns="0" rIns="0" tIns="0" bIns="0">
+            <a:spAutoFit/>
+          </a:bodyPr>
+          <a:lstStyle/>
+          <a:p>
+            <a:pPr algn="l"/>
+            <a:r>
+              <a:rPr sz="825" b="0">
+                <a:solidFill>
+                  <a:srgbClr val="5C6B73"/>
+                </a:solidFill>
+                <a:latin typeface="Liter"/>
+              </a:rPr>
+              <a:t>GHAZI MABROUKI</a:t>
+            </a:r>
+          </a:p>
+        </p:txBody>
+      </p:sp>
+      <p:sp>
+        <p:nvSpPr>
+          <p:cNvPr id="7" name="dsl:footer-page"/>
+          <p:cNvSpPr txBox="1"/>
+          <p:nvPr/>
+        </p:nvSpPr>
+        <p:spPr>
+          <a:xfrm>
+            <a:off x="11334902" y="6629400"/>
+            <a:ext cx="381304" cy="152704"/>
+          </a:xfrm>
+          <a:prstGeom prst="rect">
+            <a:avLst/>
+          </a:prstGeom>
+          <a:noFill/>
+        </p:spPr>
+        <p:txBody>
+          <a:bodyPr wrap="square" lIns="0" rIns="0" tIns="0" bIns="0">
+            <a:spAutoFit/>
+          </a:bodyPr>
+          <a:lstStyle/>
+          <a:p>
+            <a:pPr algn="r"/>
+            <a:r>
+              <a:rPr sz="900" b="0">
+                <a:solidFill>
+                  <a:srgbClr val="5C6B73"/>
+                </a:solidFill>
+                <a:latin typeface="Liter"/>
+              </a:rPr>
+              <a:t>22</a:t>
+            </a:r>
+          </a:p>
+        </p:txBody>
+      </p:sp>
       <p:pic>
         <p:nvPicPr>
-          <p:cNvPr id="5" name="Picture 4" descr="board_tech_a.png"/>
+          <p:cNvPr id="8" name="Picture 7" descr="board_tech_a.png"/>
           <p:cNvPicPr>
             <a:picLocks noChangeAspect="1"/>
           </p:cNvPicPr>
           <p:nvPr/>
         </p:nvPicPr>
         <p:blipFill>
-          <a:blip r:embed="rId2"/>
+          <a:blip r:embed="rId4"/>
           <a:stretch>
             <a:fillRect/>
           </a:stretch>
@@ -25707,76 +25777,6 @@
           </a:prstGeom>
         </p:spPr>
       </p:pic>
-      <p:sp>
-        <p:nvSpPr>
-          <p:cNvPr id="6" name="TextBox 5"/>
-          <p:cNvSpPr txBox="1"/>
-          <p:nvPr/>
-        </p:nvSpPr>
-        <p:spPr>
-          <a:xfrm>
-            <a:off x="571500" y="6629400"/>
-            <a:ext cx="1904695" cy="152704"/>
-          </a:xfrm>
-          <a:prstGeom prst="rect">
-            <a:avLst/>
-          </a:prstGeom>
-          <a:noFill/>
-        </p:spPr>
-        <p:txBody>
-          <a:bodyPr wrap="square" lIns="0" rIns="0" tIns="0" bIns="0">
-            <a:spAutoFit/>
-          </a:bodyPr>
-          <a:lstStyle/>
-          <a:p>
-            <a:pPr algn="l"/>
-            <a:r>
-              <a:rPr sz="825" b="0">
-                <a:solidFill>
-                  <a:srgbClr val="5C6B73"/>
-                </a:solidFill>
-                <a:latin typeface="Liter"/>
-              </a:rPr>
-              <a:t>GHAZI MABROUKI</a:t>
-            </a:r>
-          </a:p>
-        </p:txBody>
-      </p:sp>
-      <p:sp>
-        <p:nvSpPr>
-          <p:cNvPr id="7" name="dsl:footer-page"/>
-          <p:cNvSpPr txBox="1"/>
-          <p:nvPr/>
-        </p:nvSpPr>
-        <p:spPr>
-          <a:xfrm>
-            <a:off x="11334902" y="6629400"/>
-            <a:ext cx="381304" cy="152704"/>
-          </a:xfrm>
-          <a:prstGeom prst="rect">
-            <a:avLst/>
-          </a:prstGeom>
-          <a:noFill/>
-        </p:spPr>
-        <p:txBody>
-          <a:bodyPr wrap="square" lIns="0" rIns="0" tIns="0" bIns="0">
-            <a:spAutoFit/>
-          </a:bodyPr>
-          <a:lstStyle/>
-          <a:p>
-            <a:pPr algn="r"/>
-            <a:r>
-              <a:rPr sz="900" b="0">
-                <a:solidFill>
-                  <a:srgbClr val="5C6B73"/>
-                </a:solidFill>
-                <a:latin typeface="Liter"/>
-              </a:rPr>
-              <a:t>22</a:t>
-            </a:r>
-          </a:p>
-        </p:txBody>
-      </p:sp>
     </p:spTree>
   </p:cSld>
   <p:clrMapOvr>

</xml_diff>